<commit_message>
Rimuovi hint navigazione, espandi TDD in Test-Driven Development
</commit_message>
<xml_diff>
--- a/vibe-coding-genomedics.pptx
+++ b/vibe-coding-genomedics.pptx
@@ -4015,8 +4015,8 @@
         </p:nvSpPr>
         <p:spPr>
           <a:xfrm>
-            <a:off x="841248" y="4462272"/>
-            <a:ext cx="10506456" cy="960120"/>
+            <a:off x="841248" y="4434840"/>
+            <a:ext cx="10506456" cy="1097280"/>
           </a:xfrm>
           <a:prstGeom prst="roundRect">
             <a:avLst>
@@ -4063,8 +4063,8 @@
         </p:nvSpPr>
         <p:spPr>
           <a:xfrm>
-            <a:off x="1188720" y="4608576"/>
-            <a:ext cx="9966960" cy="411480"/>
+            <a:off x="1188720" y="4562856"/>
+            <a:ext cx="9966960" cy="685800"/>
           </a:xfrm>
           <a:prstGeom prst="rect">
             <a:avLst/>
@@ -4077,7 +4077,11 @@
           </a:bodyPr>
           <a:lstStyle/>
           <a:p>
-            <a:pPr algn="l"/>
+            <a:pPr algn="l">
+              <a:lnSpc>
+                <a:spcPct val="112000"/>
+              </a:lnSpc>
+            </a:pPr>
             <a:r>
               <a:rPr sz="1450" b="1" i="0">
                 <a:solidFill>
@@ -4094,7 +4098,7 @@
                 </a:solidFill>
                 <a:latin typeface="Segoe UI"/>
               </a:rPr>
-              <a:t>insegnale a verificarsi da sola — quali test, quale output. È ciò che rende veloce il TDD.</a:t>
+              <a:t>insegnale a verificarsi da sola — quali test, quale output. È ciò che rende veloce il TDD (Test-Driven Development).</a:t>
             </a:r>
           </a:p>
         </p:txBody>
@@ -4107,7 +4111,7 @@
         </p:nvSpPr>
         <p:spPr>
           <a:xfrm>
-            <a:off x="1188720" y="5020056"/>
+            <a:off x="1188720" y="5138928"/>
             <a:ext cx="9966960" cy="320040"/>
           </a:xfrm>
           <a:prstGeom prst="rect">
@@ -4142,8 +4146,8 @@
         </p:nvSpPr>
         <p:spPr>
           <a:xfrm>
-            <a:off x="841248" y="5559552"/>
-            <a:ext cx="10506456" cy="566928"/>
+            <a:off x="841248" y="5687568"/>
+            <a:ext cx="10506456" cy="530352"/>
           </a:xfrm>
           <a:prstGeom prst="roundRect">
             <a:avLst>
@@ -4190,8 +4194,8 @@
         </p:nvSpPr>
         <p:spPr>
           <a:xfrm>
-            <a:off x="1188720" y="5559552"/>
-            <a:ext cx="9966960" cy="566928"/>
+            <a:off x="1188720" y="5687568"/>
+            <a:ext cx="9966960" cy="530352"/>
           </a:xfrm>
           <a:prstGeom prst="rect">
             <a:avLst/>

</xml_diff>

<commit_message>
Aggiungi QR alla slide finale (link presentazione)
</commit_message>
<xml_diff>
--- a/vibe-coding-genomedics.pptx
+++ b/vibe-coding-genomedics.pptx
@@ -4604,7 +4604,7 @@
         <p:spPr>
           <a:xfrm>
             <a:off x="841248" y="6080760"/>
-            <a:ext cx="10515600" cy="365760"/>
+            <a:ext cx="8229600" cy="365760"/>
           </a:xfrm>
           <a:prstGeom prst="rect">
             <a:avLst/>
@@ -4626,6 +4626,111 @@
                 <a:latin typeface="Segoe UI"/>
               </a:rPr>
               <a:t>Gianluca Braccini    ·    linkedin.com/in/gianlucabraccini    ·    github.com/gbraccini</a:t>
+            </a:r>
+          </a:p>
+        </p:txBody>
+      </p:sp>
+      <p:sp>
+        <p:nvSpPr>
+          <p:cNvPr id="12" name="Rounded Rectangle 11"/>
+          <p:cNvSpPr/>
+          <p:nvPr/>
+        </p:nvSpPr>
+        <p:spPr>
+          <a:xfrm>
+            <a:off x="9509760" y="4069080"/>
+            <a:ext cx="1783080" cy="1810512"/>
+          </a:xfrm>
+          <a:prstGeom prst="roundRect">
+            <a:avLst>
+              <a:gd name="adj" fmla="val 7000"/>
+            </a:avLst>
+          </a:prstGeom>
+          <a:solidFill>
+            <a:srgbClr val="FFFFFF"/>
+          </a:solidFill>
+          <a:ln>
+            <a:noFill/>
+          </a:ln>
+          <a:effectLst/>
+        </p:spPr>
+        <p:style>
+          <a:lnRef idx="1">
+            <a:schemeClr val="accent1"/>
+          </a:lnRef>
+          <a:fillRef idx="3">
+            <a:schemeClr val="accent1"/>
+          </a:fillRef>
+          <a:effectRef idx="2">
+            <a:schemeClr val="accent1"/>
+          </a:effectRef>
+          <a:fontRef idx="minor">
+            <a:schemeClr val="lt1"/>
+          </a:fontRef>
+        </p:style>
+        <p:txBody>
+          <a:bodyPr rtlCol="0" anchor="ctr"/>
+          <a:lstStyle/>
+          <a:p>
+            <a:pPr algn="ctr"/>
+          </a:p>
+        </p:txBody>
+      </p:sp>
+      <p:pic>
+        <p:nvPicPr>
+          <p:cNvPr id="13" name="Picture 12" descr="qr.png"/>
+          <p:cNvPicPr>
+            <a:picLocks noChangeAspect="1"/>
+          </p:cNvPicPr>
+          <p:nvPr/>
+        </p:nvPicPr>
+        <p:blipFill>
+          <a:blip r:embed="rId4"/>
+          <a:stretch>
+            <a:fillRect/>
+          </a:stretch>
+        </p:blipFill>
+        <p:spPr>
+          <a:xfrm>
+            <a:off x="9756648" y="4224528"/>
+            <a:ext cx="1289304" cy="1289304"/>
+          </a:xfrm>
+          <a:prstGeom prst="rect">
+            <a:avLst/>
+          </a:prstGeom>
+        </p:spPr>
+      </p:pic>
+      <p:sp>
+        <p:nvSpPr>
+          <p:cNvPr id="14" name="TextBox 13"/>
+          <p:cNvSpPr txBox="1"/>
+          <p:nvPr/>
+        </p:nvSpPr>
+        <p:spPr>
+          <a:xfrm>
+            <a:off x="9555480" y="5541264"/>
+            <a:ext cx="1691640" cy="310896"/>
+          </a:xfrm>
+          <a:prstGeom prst="rect">
+            <a:avLst/>
+          </a:prstGeom>
+          <a:noFill/>
+        </p:spPr>
+        <p:txBody>
+          <a:bodyPr wrap="square" anchor="t" lIns="0" rIns="0" tIns="0" bIns="0">
+            <a:spAutoFit/>
+          </a:bodyPr>
+          <a:lstStyle/>
+          <a:p>
+            <a:pPr algn="ctr"/>
+            <a:r>
+              <a:rPr sz="900" b="1" i="0">
+                <a:solidFill>
+                  <a:srgbClr val="1A1F2E"/>
+                </a:solidFill>
+                <a:latin typeface="Segoe UI"/>
+              </a:rPr>
+              <a:t>Inquadra per le slide</a:t>
             </a:r>
           </a:p>
         </p:txBody>

</xml_diff>

<commit_message>
Sposta QR in basso a sinistra accanto ai contatti
</commit_message>
<xml_diff>
--- a/vibe-coding-genomedics.pptx
+++ b/vibe-coding-genomedics.pptx
@@ -4507,8 +4507,8 @@
         </p:nvSpPr>
         <p:spPr>
           <a:xfrm>
-            <a:off x="841248" y="4526280"/>
-            <a:ext cx="7680960" cy="960120"/>
+            <a:off x="841248" y="4206240"/>
+            <a:ext cx="7680960" cy="914400"/>
           </a:xfrm>
           <a:prstGeom prst="roundRect">
             <a:avLst>
@@ -4555,7 +4555,7 @@
         </p:nvSpPr>
         <p:spPr>
           <a:xfrm>
-            <a:off x="1143000" y="4718304"/>
+            <a:off x="1143000" y="4389120"/>
             <a:ext cx="7132320" cy="640080"/>
           </a:xfrm>
           <a:prstGeom prst="rect">
@@ -4597,53 +4597,18 @@
       </p:sp>
       <p:sp>
         <p:nvSpPr>
-          <p:cNvPr id="11" name="TextBox 10"/>
-          <p:cNvSpPr txBox="1"/>
-          <p:nvPr/>
-        </p:nvSpPr>
-        <p:spPr>
-          <a:xfrm>
-            <a:off x="841248" y="6080760"/>
-            <a:ext cx="8229600" cy="365760"/>
-          </a:xfrm>
-          <a:prstGeom prst="rect">
-            <a:avLst/>
-          </a:prstGeom>
-          <a:noFill/>
-        </p:spPr>
-        <p:txBody>
-          <a:bodyPr wrap="square" anchor="t" lIns="0" rIns="0" tIns="0" bIns="0">
-            <a:spAutoFit/>
-          </a:bodyPr>
-          <a:lstStyle/>
-          <a:p>
-            <a:pPr algn="l"/>
-            <a:r>
-              <a:rPr sz="1250" b="0" i="1">
-                <a:solidFill>
-                  <a:srgbClr val="C9D2DC"/>
-                </a:solidFill>
-                <a:latin typeface="Segoe UI"/>
-              </a:rPr>
-              <a:t>Gianluca Braccini    ·    linkedin.com/in/gianlucabraccini    ·    github.com/gbraccini</a:t>
-            </a:r>
-          </a:p>
-        </p:txBody>
-      </p:sp>
-      <p:sp>
-        <p:nvSpPr>
-          <p:cNvPr id="12" name="Rounded Rectangle 11"/>
+          <p:cNvPr id="11" name="Rounded Rectangle 10"/>
           <p:cNvSpPr/>
           <p:nvPr/>
         </p:nvSpPr>
         <p:spPr>
           <a:xfrm>
-            <a:off x="9509760" y="4069080"/>
-            <a:ext cx="1783080" cy="1810512"/>
+            <a:off x="841248" y="5413248"/>
+            <a:ext cx="1225296" cy="1225296"/>
           </a:xfrm>
           <a:prstGeom prst="roundRect">
             <a:avLst>
-              <a:gd name="adj" fmla="val 7000"/>
+              <a:gd name="adj" fmla="val 9000"/>
             </a:avLst>
           </a:prstGeom>
           <a:solidFill>
@@ -4678,7 +4643,7 @@
       </p:sp>
       <p:pic>
         <p:nvPicPr>
-          <p:cNvPr id="13" name="Picture 12" descr="qr.png"/>
+          <p:cNvPr id="12" name="Picture 11" descr="qr.png"/>
           <p:cNvPicPr>
             <a:picLocks noChangeAspect="1"/>
           </p:cNvPicPr>
@@ -4692,8 +4657,8 @@
         </p:blipFill>
         <p:spPr>
           <a:xfrm>
-            <a:off x="9756648" y="4224528"/>
-            <a:ext cx="1289304" cy="1289304"/>
+            <a:off x="905256" y="5477256"/>
+            <a:ext cx="1097280" cy="1097280"/>
           </a:xfrm>
           <a:prstGeom prst="rect">
             <a:avLst/>
@@ -4702,14 +4667,49 @@
       </p:pic>
       <p:sp>
         <p:nvSpPr>
+          <p:cNvPr id="13" name="TextBox 12"/>
+          <p:cNvSpPr txBox="1"/>
+          <p:nvPr/>
+        </p:nvSpPr>
+        <p:spPr>
+          <a:xfrm>
+            <a:off x="2286000" y="5650992"/>
+            <a:ext cx="8686800" cy="320040"/>
+          </a:xfrm>
+          <a:prstGeom prst="rect">
+            <a:avLst/>
+          </a:prstGeom>
+          <a:noFill/>
+        </p:spPr>
+        <p:txBody>
+          <a:bodyPr wrap="square" anchor="t" lIns="0" rIns="0" tIns="0" bIns="0">
+            <a:spAutoFit/>
+          </a:bodyPr>
+          <a:lstStyle/>
+          <a:p>
+            <a:pPr algn="l"/>
+            <a:r>
+              <a:rPr sz="1200" b="1" i="0">
+                <a:solidFill>
+                  <a:srgbClr val="2DD4BF"/>
+                </a:solidFill>
+                <a:latin typeface="Segoe UI"/>
+              </a:rPr>
+              <a:t>Inquadra il QR per le slide online</a:t>
+            </a:r>
+          </a:p>
+        </p:txBody>
+      </p:sp>
+      <p:sp>
+        <p:nvSpPr>
           <p:cNvPr id="14" name="TextBox 13"/>
           <p:cNvSpPr txBox="1"/>
           <p:nvPr/>
         </p:nvSpPr>
         <p:spPr>
           <a:xfrm>
-            <a:off x="9555480" y="5541264"/>
-            <a:ext cx="1691640" cy="310896"/>
+            <a:off x="2286000" y="6053328"/>
+            <a:ext cx="9601200" cy="320040"/>
           </a:xfrm>
           <a:prstGeom prst="rect">
             <a:avLst/>
@@ -4722,15 +4722,15 @@
           </a:bodyPr>
           <a:lstStyle/>
           <a:p>
-            <a:pPr algn="ctr"/>
-            <a:r>
-              <a:rPr sz="900" b="1" i="0">
-                <a:solidFill>
-                  <a:srgbClr val="1A1F2E"/>
-                </a:solidFill>
-                <a:latin typeface="Segoe UI"/>
-              </a:rPr>
-              <a:t>Inquadra per le slide</a:t>
+            <a:pPr algn="l"/>
+            <a:r>
+              <a:rPr sz="1200" b="0" i="1">
+                <a:solidFill>
+                  <a:srgbClr val="C9D2DC"/>
+                </a:solidFill>
+                <a:latin typeface="Segoe UI"/>
+              </a:rPr>
+              <a:t>Gianluca Braccini    ·    linkedin.com/in/gianlucabraccini    ·    github.com/gbraccini</a:t>
             </a:r>
           </a:p>
         </p:txBody>

</xml_diff>